<commit_message>
Slides: bring the last three sd-06 lines to 10 words; re-export PPTX
Co-Authored-By: Claude Sonnet 5.5 <noreply@anthropic.com>
Claude-Session: https://claude.ai/code/session_01XSxLqDPHaDeZhrxWwesxJf
</commit_message>
<xml_diff>
--- a/system-design-101/vi/lessons/sd-06-003/slides/sd-06-003.pptx
+++ b/system-design-101/vi/lessons/sd-06-003/slides/sd-06-003.pptx
@@ -1805,7 +1805,7 @@
               <a:t> tới</a:t>
             </a:r>
             <a:r>
-              <a:rPr lang="en-US" sz="7500" dirty="0" spc="0" kern="0">
+              <a:rPr lang="en-US" sz="7500" dirty="0" spc="-72" kern="0">
                 <a:solidFill>
                   <a:srgbClr val="F3EEE3"/>
                 </a:solidFill>
@@ -1813,21 +1813,10 @@
                 <a:ea typeface="Bricolage Grotesque ExtraBold" pitchFamily="34" charset="-122"/>
                 <a:cs typeface="Bricolage Grotesque ExtraBold" pitchFamily="34" charset="-120"/>
               </a:rPr>
-              <a:t> lưu</a:t>
-            </a:r>
-            <a:r>
-              <a:rPr lang="en-US" sz="7500" dirty="0" spc="-71" kern="0">
-                <a:solidFill>
-                  <a:srgbClr val="F3EEE3"/>
-                </a:solidFill>
-                <a:latin typeface="Bricolage Grotesque ExtraBold" pitchFamily="34" charset="0"/>
-                <a:ea typeface="Bricolage Grotesque ExtraBold" pitchFamily="34" charset="-122"/>
-                <a:cs typeface="Bricolage Grotesque ExtraBold" pitchFamily="34" charset="-120"/>
-              </a:rPr>
               <a:t> AOF</a:t>
             </a:r>
             <a:r>
-              <a:rPr lang="en-US" sz="7500" dirty="0" spc="0" kern="0">
+              <a:rPr lang="en-US" sz="7500" dirty="0" spc="1" kern="0">
                 <a:solidFill>
                   <a:srgbClr val="F3EEE3"/>
                 </a:solidFill>

</xml_diff>